<commit_message>
test(fixture): layout 1 carries the date/footer/slide-number trio
A real PowerPoint layout declares `dt`, `ftr` and `sldNum` slots alongside its
title and body; the hand-authored fixture had none, so the slots a slide
inherits rather than owns could not be tested at all. Layout 2's shape tree
gains the three, sized `half` at `idx` 10/11/12, as PowerPoint writes them.
</commit_message>
<xml_diff>
--- a/tests/fixtures/layouts.pptx
+++ b/tests/fixtures/layouts.pptx
@@ -130,6 +130,81 @@
           <a:xfrm>
             <a:off x="685800" y="1828800"/>
             <a:ext cx="7772400" cy="3886200"/>
+          </a:xfrm>
+          <a:prstGeom prst="rect">
+            <a:avLst/>
+          </a:prstGeom>
+        </p:spPr>
+        <p:txBody>
+          <a:bodyPr/>
+          <a:lstStyle/>
+          <a:p/>
+        </p:txBody>
+      </p:sp>
+      <p:sp>
+        <p:nvSpPr>
+          <p:cNvPr id="4" name="Date Placeholder 3"/>
+          <p:cNvSpPr>
+            <a:spLocks noGrp="1"/>
+          </p:cNvSpPr>
+          <p:nvPr>
+            <p:ph type="dt" sz="half" idx="10"/>
+          </p:nvPr>
+        </p:nvSpPr>
+        <p:spPr>
+          <a:xfrm>
+            <a:off x="685800" y="6356350"/>
+            <a:ext cx="2057400" cy="365125"/>
+          </a:xfrm>
+          <a:prstGeom prst="rect">
+            <a:avLst/>
+          </a:prstGeom>
+        </p:spPr>
+        <p:txBody>
+          <a:bodyPr/>
+          <a:lstStyle/>
+          <a:p/>
+        </p:txBody>
+      </p:sp>
+      <p:sp>
+        <p:nvSpPr>
+          <p:cNvPr id="5" name="Footer Placeholder 4"/>
+          <p:cNvSpPr>
+            <a:spLocks noGrp="1"/>
+          </p:cNvSpPr>
+          <p:nvPr>
+            <p:ph type="ftr" sz="half" idx="11"/>
+          </p:nvPr>
+        </p:nvSpPr>
+        <p:spPr>
+          <a:xfrm>
+            <a:off x="3000000" y="6356350"/>
+            <a:ext cx="2057400" cy="365125"/>
+          </a:xfrm>
+          <a:prstGeom prst="rect">
+            <a:avLst/>
+          </a:prstGeom>
+        </p:spPr>
+        <p:txBody>
+          <a:bodyPr/>
+          <a:lstStyle/>
+          <a:p/>
+        </p:txBody>
+      </p:sp>
+      <p:sp>
+        <p:nvSpPr>
+          <p:cNvPr id="6" name="Slide Number Placeholder 5"/>
+          <p:cNvSpPr>
+            <a:spLocks noGrp="1"/>
+          </p:cNvSpPr>
+          <p:nvPr>
+            <p:ph type="sldNum" sz="half" idx="12"/>
+          </p:nvPr>
+        </p:nvSpPr>
+        <p:spPr>
+          <a:xfrm>
+            <a:off x="6400800" y="6356350"/>
+            <a:ext cx="2057400" cy="365125"/>
           </a:xfrm>
           <a:prstGeom prst="rect">
             <a:avLst/>

</xml_diff>

<commit_message>
test(fixture): levels the master actually distinguishes
`layouts.pptx`'s master styled only `lvl1pPr`, so no test could show a demoted
paragraph resolving to a *different* answer — the thing the level axis exists
for. `p:bodyStyle` now defines three levels with distinct `buChar` / `sz` /
`marL`, and slideLayout2's `idx="1"` placeholder carries a non-empty
`a:lstStyle` (`b="1"`) so the layout-placeholder tier has something to say.

Additive: the deck's existing assertions are untouched, and `sample.pptx` keeps
its missing `p:txStyles` as the absent-tier path.
</commit_message>
<xml_diff>
--- a/tests/fixtures/layouts.pptx
+++ b/tests/fixtures/layouts.pptx
@@ -137,7 +137,11 @@
         </p:spPr>
         <p:txBody>
           <a:bodyPr/>
-          <a:lstStyle/>
+          <a:lstStyle>
+            <a:lvl1pPr>
+              <a:defRPr b="1"/>
+            </a:lvl1pPr>
+          </a:lstStyle>
           <a:p/>
         </p:txBody>
       </p:sp>
@@ -317,9 +321,18 @@
       </a:lvl1pPr>
     </p:titleStyle>
     <p:bodyStyle>
-      <a:lvl1pPr>
+      <a:lvl1pPr marL="342900" indent="-342900">
+        <a:buChar char="•"/>
         <a:defRPr sz="3200"/>
       </a:lvl1pPr>
+      <a:lvl2pPr marL="742950" indent="-285750">
+        <a:buChar char="–"/>
+        <a:defRPr sz="2800"/>
+      </a:lvl2pPr>
+      <a:lvl3pPr marL="1143000" indent="-228600">
+        <a:buChar char="»"/>
+        <a:defRPr sz="2400"/>
+      </a:lvl3pPr>
     </p:bodyStyle>
     <p:otherStyle>
       <a:lvl1pPr>

</xml_diff>

<commit_message>
test(fixture): a group and a table, so the exotic paths meet a real file
Every fixture held only `p:sp`, so the two shape kinds whose transform is somewhere unusual could
only ever be tested as XML fragments. Slide 2 of layouts.pptx gains a `p:grpSp` and a
`p:graphicFrame`, appended, so shape indices 0 and 1 keep their meaning and no existing test moves.

The group's child coordinate space is deliberately *not* its extent — `a:chOff`/`a:chExt` name a
different origin and a larger space than `a:off`/`a:ext` — so a test that moves the group can prove
the child space came through untouched rather than coincidentally matching.

The graphic frame holds a real one-cell table rather than an empty `a:graphic`, so LibreOffice still
opens the deck (the canary reads this fixture), and so the tables workstream inherits a fixture
instead of authoring one.
</commit_message>
<xml_diff>
--- a/tests/fixtures/layouts.pptx
+++ b/tests/fixtures/layouts.pptx
@@ -491,6 +491,101 @@
           </a:p>
         </p:txBody>
       </p:sp>
+      <p:grpSp>
+        <p:nvGrpSpPr>
+          <p:cNvPr id="4" name="Group 3"/>
+          <p:cNvGrpSpPr/>
+          <p:nvPr/>
+        </p:nvGrpSpPr>
+        <p:grpSpPr>
+          <a:xfrm>
+            <a:off x="457200" y="365125"/>
+            <a:ext cx="1828800" cy="914400"/>
+            <a:chOff x="1000000" y="2000000"/>
+            <a:chExt cx="3657600" cy="1828800"/>
+          </a:xfrm>
+        </p:grpSpPr>
+        <p:sp>
+          <p:nvSpPr>
+            <p:cNvPr id="5" name="Rectangle 4"/>
+            <p:cNvSpPr/>
+            <p:nvPr/>
+          </p:nvSpPr>
+          <p:spPr>
+            <a:xfrm>
+              <a:off x="1000000" y="2000000"/>
+              <a:ext cx="1828800" cy="1828800"/>
+            </a:xfrm>
+            <a:prstGeom prst="rect">
+              <a:avLst/>
+            </a:prstGeom>
+          </p:spPr>
+          <p:txBody>
+            <a:bodyPr/>
+            <a:lstStyle/>
+            <a:p/>
+          </p:txBody>
+        </p:sp>
+        <p:sp>
+          <p:nvSpPr>
+            <p:cNvPr id="6" name="Rectangle 5"/>
+            <p:cNvSpPr/>
+            <p:nvPr/>
+          </p:nvSpPr>
+          <p:spPr>
+            <a:xfrm>
+              <a:off x="2828800" y="2000000"/>
+              <a:ext cx="1828800" cy="1828800"/>
+            </a:xfrm>
+            <a:prstGeom prst="ellipse">
+              <a:avLst/>
+            </a:prstGeom>
+          </p:spPr>
+          <p:txBody>
+            <a:bodyPr/>
+            <a:lstStyle/>
+            <a:p/>
+          </p:txBody>
+        </p:sp>
+      </p:grpSp>
+      <p:graphicFrame>
+        <p:nvGraphicFramePr>
+          <p:cNvPr id="7" name="Table 6"/>
+          <p:cNvGraphicFramePr>
+            <a:graphicFrameLocks noGrp="1"/>
+          </p:cNvGraphicFramePr>
+          <p:nvPr/>
+        </p:nvGraphicFramePr>
+        <p:xfrm>
+          <a:off x="5486400" y="365125"/>
+          <a:ext cx="3048000" cy="370840"/>
+        </p:xfrm>
+        <a:graphic>
+          <a:graphicData uri="http://schemas.openxmlformats.org/drawingml/2006/table">
+            <a:tbl>
+              <a:tblPr firstRow="1" bandRow="1"/>
+              <a:tblGrid>
+                <a:gridCol w="3048000"/>
+              </a:tblGrid>
+              <a:tr h="370840">
+                <a:tc>
+                  <a:txBody>
+                    <a:bodyPr/>
+                    <a:lstStyle/>
+                    <a:p>
+                      <a:r>
+                        <a:rPr lang="en-US" dirty="0"/>
+                        <a:t>Cell</a:t>
+                      </a:r>
+                    </a:p>
+                  </a:txBody>
+                  <a:tcPr/>
+                </a:tc>
+              </a:tr>
+            </a:tbl>
+          </a:graphicData>
+        </a:graphic>
+      </p:graphicFrame>
     </p:spTree>
   </p:cSld>
   <p:clrMapOvr>

</xml_diff>

<commit_message>
test(fixture): a layout that defers its title to the master
Every placeholder in layouts.pptx placed itself, so the inheritance walk could never get past the
first tier and the master tier was untestable. slideLayout2's title placeholder now declares no
`a:xfrm` — ordinary in real decks, where a layout overrides only the slots it means to move.

One removed element buys both tiers from one deck: a slide built from that layout resolves its title
at the master and its body at the layout, so a single test can show the walk stopping at different
tiers for different shapes rather than picking one tier per slide.

`Surface::Layout(0)` is untouched, so the transform tests that edit it are unaffected, and
LibreOffice still opens the deck.
</commit_message>
<xml_diff>
--- a/tests/fixtures/layouts.pptx
+++ b/tests/fixtures/layouts.pptx
@@ -102,10 +102,6 @@
           </p:nvPr>
         </p:nvSpPr>
         <p:spPr>
-          <a:xfrm>
-            <a:off x="685800" y="457200"/>
-            <a:ext cx="7772400" cy="1143000"/>
-          </a:xfrm>
           <a:prstGeom prst="rect">
             <a:avLst/>
           </a:prstGeom>

</xml_diff>